<commit_message>
docs: record full-stack market desk verification
</commit_message>
<xml_diff>
--- a/docs/London-Market-Desk-Architecture-and-Demo-2026-08-02.pptx
+++ b/docs/London-Market-Desk-Architecture-and-Demo-2026-08-02.pptx
@@ -2,18 +2,18 @@
 <file path=ppt/presentation.xml><?xml version="1.0" encoding="utf-8"?>
 <p:presentation xmlns:p="http://schemas.openxmlformats.org/presentationml/2006/main">
   <p:sldMasterIdLst>
-    <p:sldMasterId xmlns:r="http://schemas.openxmlformats.org/officeDocument/2006/relationships" id="2147483648" r:id="R138733f396e24016"/>
+    <p:sldMasterId xmlns:r="http://schemas.openxmlformats.org/officeDocument/2006/relationships" id="2147483648" r:id="Re2dde098ffc94afc"/>
   </p:sldMasterIdLst>
   <p:notesMasterIdLst>
-    <p:notesMasterId xmlns:r="http://schemas.openxmlformats.org/officeDocument/2006/relationships" r:id="Ra66eedae46954dfa"/>
+    <p:notesMasterId xmlns:r="http://schemas.openxmlformats.org/officeDocument/2006/relationships" r:id="R78182f0f0b514020"/>
   </p:notesMasterIdLst>
   <p:sldIdLst>
-    <p:sldId xmlns:r="http://schemas.openxmlformats.org/officeDocument/2006/relationships" id="256" r:id="Rf9f97dd1e6c24124"/>
-    <p:sldId xmlns:r="http://schemas.openxmlformats.org/officeDocument/2006/relationships" id="257" r:id="Rf27871beed3b4799"/>
-    <p:sldId xmlns:r="http://schemas.openxmlformats.org/officeDocument/2006/relationships" id="258" r:id="R0bc7e5017c9f4b50"/>
-    <p:sldId xmlns:r="http://schemas.openxmlformats.org/officeDocument/2006/relationships" id="259" r:id="R3cd4905b763542b1"/>
-    <p:sldId xmlns:r="http://schemas.openxmlformats.org/officeDocument/2006/relationships" id="260" r:id="Rc46c49421b244d92"/>
-    <p:sldId xmlns:r="http://schemas.openxmlformats.org/officeDocument/2006/relationships" id="261" r:id="Rcea8175e5e6d4eab"/>
+    <p:sldId xmlns:r="http://schemas.openxmlformats.org/officeDocument/2006/relationships" id="256" r:id="R93adae1eb803462e"/>
+    <p:sldId xmlns:r="http://schemas.openxmlformats.org/officeDocument/2006/relationships" id="257" r:id="Rba3c77ec2b374b38"/>
+    <p:sldId xmlns:r="http://schemas.openxmlformats.org/officeDocument/2006/relationships" id="258" r:id="R5e72c8d7397943ef"/>
+    <p:sldId xmlns:r="http://schemas.openxmlformats.org/officeDocument/2006/relationships" id="259" r:id="R7e6957868f6d487d"/>
+    <p:sldId xmlns:r="http://schemas.openxmlformats.org/officeDocument/2006/relationships" id="260" r:id="R72b6dfa117d9468e"/>
+    <p:sldId xmlns:r="http://schemas.openxmlformats.org/officeDocument/2006/relationships" id="261" r:id="R4b08025d34a14976"/>
   </p:sldIdLst>
   <p:sldSz cx="12192000" cy="6858000"/>
   <p:notesSz cx="6858000" cy="9144000"/>
@@ -642,28 +642,27 @@
           </a:p>
           <a:p xmlns:a="http://schemas.openxmlformats.org/drawingml/2006/main">
             <a:r>
-              <a:t>- docs/first-use-and-data-pipeline.md</a:t>
-            </a:r>
-          </a:p>
-          <a:p xmlns:a="http://schemas.openxmlformats.org/drawingml/2006/main">
-            <a:r>
-              <a:t>- wiki/questions/Test_result/TC-01-runtime-live-test-2026-08-02.md</a:t>
-            </a:r>
-          </a:p>
-          <a:p xmlns:a="http://schemas.openxmlformats.org/drawingml/2006/main">
-            <a:r>
-              <a:t>- wiki/questions/Test_result/TC-01-dashboard-ui-test-2026-08-02.md</a:t>
-            </a:r>
-          </a:p>
-          <a:p xmlns:a="http://schemas.openxmlformats.org/drawingml/2006/main">
-            <a:r>
-              <a:t>
-[Sources]
-- wiki/research/datasource/01-office-rent.md through 13-submarket-geography.md (13 category/source mappings)
-- src/nan_fung/datasources/catalog.py (operational, blocked, manual_review and legacy_adapter states)
-- docs/datasource-acceptance.md (product-coverage gates and TC-01 reason)
-- agent-runtime/README.md; agent-runtime/src/server.ts; agent-runtime/skills.manifest.json (Bank Rate-only production allowlist and preloaded skills)
-- skills/*/SKILL.md (research runbooks shown in the Tool / Skill column)</a:t>
+              <a:t>- wiki/research/datasource/01-office-rent.md through 13-submarket-geography.md (13 category/source mappings)</a:t>
+            </a:r>
+          </a:p>
+          <a:p xmlns:a="http://schemas.openxmlformats.org/drawingml/2006/main">
+            <a:r>
+              <a:t>- src/nan_fung/datasources/catalog.py (operational, blocked, manual_review and legacy_adapter states)</a:t>
+            </a:r>
+          </a:p>
+          <a:p xmlns:a="http://schemas.openxmlformats.org/drawingml/2006/main">
+            <a:r>
+              <a:t>- docs/datasource-acceptance.md (product-coverage gates and TC-01 reason)</a:t>
+            </a:r>
+          </a:p>
+          <a:p xmlns:a="http://schemas.openxmlformats.org/drawingml/2006/main">
+            <a:r>
+              <a:t>- agent-runtime/README.md; agent-runtime/src/server.ts; agent-runtime/skills.manifest.json (Bank Rate-only production allowlist and preloaded skills)</a:t>
+            </a:r>
+          </a:p>
+          <a:p xmlns:a="http://schemas.openxmlformats.org/drawingml/2006/main">
+            <a:r>
+              <a:t>- skills/*/SKILL.md (research runbooks shown in the Tool / Skill column)</a:t>
             </a:r>
           </a:p>
         </p:txBody>
@@ -733,7 +732,7 @@
           <a:lstStyle xmlns:a="http://schemas.openxmlformats.org/drawingml/2006/main"/>
           <a:p xmlns:a="http://schemas.openxmlformats.org/drawingml/2006/main">
             <a:r>
-              <a:t>Live runtime test 的 Bank Rate chain 已實際走過 describe、query、citation metadata 與 finalize；TC-01 中文題則完成 unavailable brief 且 facts 與 sources 均為 0。</a:t>
+              <a:t>流程圖解說：1) 使用者問題建立 session scope；2) host 驗證並預載 Skills，將 Pi turn 限制為 45 秒；3) Pi 只可選用五個 typed data tools；4) Python Facade 套用 scoped handle、budget 和 read-only canonical boundary；5) query/citation 結果寫入 host-owned ledger；6) runtime-only finalizer 核對 claim/citation，產生 market_brief.v1；7) SSE 僅輸出已驗證的 final artifact。</a:t>
             </a:r>
           </a:p>
           <a:p xmlns:a="http://schemas.openxmlformats.org/drawingml/2006/main">
@@ -748,7 +747,22 @@
           </a:p>
           <a:p xmlns:a="http://schemas.openxmlformats.org/drawingml/2006/main">
             <a:r>
-              <a:t>- wiki/questions/Test_result/TC-01-runtime-live-test-2026-08-02.md</a:t>
+              <a:t>- agent-runtime/README.md (controlled tool surface and market_brief.v1 contract)</a:t>
+            </a:r>
+          </a:p>
+          <a:p xmlns:a="http://schemas.openxmlformats.org/drawingml/2006/main">
+            <a:r>
+              <a:t>- agent-runtime/src/runtime.ts (45-second turn deadline)</a:t>
+            </a:r>
+          </a:p>
+          <a:p xmlns:a="http://schemas.openxmlformats.org/drawingml/2006/main">
+            <a:r>
+              <a:t>- agent-runtime/src/turn-runner.ts (prompt deadline and Pi session abort)</a:t>
+            </a:r>
+          </a:p>
+          <a:p xmlns:a="http://schemas.openxmlformats.org/drawingml/2006/main">
+            <a:r>
+              <a:t>- wiki/architecture/agent-runtime.md (skills, Facade, finalizer, citation ledger and SSE boundary)</a:t>
             </a:r>
           </a:p>
         </p:txBody>
@@ -908,7 +922,7 @@
           <a:lstStyle xmlns:a="http://schemas.openxmlformats.org/drawingml/2006/main"/>
           <a:p xmlns:a="http://schemas.openxmlformats.org/drawingml/2006/main">
             <a:r>
-              <a:t>此頁展示 TC-01 真實對話：倫敦金融城本季 Prime office rent 的回答是 unavailable，並無 facts 或 sources。下一步是先建立有 evidence 與 freshness contract 的 canonical sources，再升級產品 coverage。</a:t>
+              <a:t>本頁全是提案中的後續能力，不是目前已交付 scope。news RAG 只應檢索 approved/licensed corpus，並把 ad-hoc evidence 和 canonical market facts 分開；intent routing 先把使用者要求送往資料查詢、refresh、新聞研究或 unavailable；任何新 office source 都要先經 evidence、freshness 和 promotion gate。</a:t>
             </a:r>
           </a:p>
           <a:p xmlns:a="http://schemas.openxmlformats.org/drawingml/2006/main">
@@ -923,17 +937,17 @@
           </a:p>
           <a:p xmlns:a="http://schemas.openxmlformats.org/drawingml/2006/main">
             <a:r>
-              <a:t>- wiki/questions/Test_result/TC-01-dashboard-ui-test-2026-08-02.md</a:t>
-            </a:r>
-          </a:p>
-          <a:p xmlns:a="http://schemas.openxmlformats.org/drawingml/2006/main">
-            <a:r>
-              <a:t>- wiki/questions/Test_result/screenshots/dashboard-tc01-unavailable.png</a:t>
-            </a:r>
-          </a:p>
-          <a:p xmlns:a="http://schemas.openxmlformats.org/drawingml/2006/main">
-            <a:r>
-              <a:t>- docs/first-use-and-data-pipeline.md</a:t>
+              <a:t>- wiki/architecture/agent-runtime.md (v1 excludes non-canonical ad-hoc results; production auth and tenant policy are deferred)</a:t>
+            </a:r>
+          </a:p>
+          <a:p xmlns:a="http://schemas.openxmlformats.org/drawingml/2006/main">
+            <a:r>
+              <a:t>- docs/datasource-acceptance.md (datasource workflow and promotion coverage context)</a:t>
+            </a:r>
+          </a:p>
+          <a:p xmlns:a="http://schemas.openxmlformats.org/drawingml/2006/main">
+            <a:r>
+              <a:t>- wiki/research/chatbot-dashboard-decision.md (chatbot/dashboard capability direction)</a:t>
             </a:r>
           </a:p>
         </p:txBody>
@@ -1001,7 +1015,7 @@
   </p:cSld>
   <p:clrMap bg1="lt1" tx1="dk1" bg2="lt2" tx2="dk2" accent1="accent1" accent2="accent2" accent3="accent3" accent4="accent4" accent5="accent5" accent6="accent6" hlink="hlink" folHlink="folHlink"/>
   <p:sldLayoutIdLst>
-    <p:sldLayoutId xmlns:r="http://schemas.openxmlformats.org/officeDocument/2006/relationships" id="2147483649" r:id="R8811c259cc5e4859"/>
+    <p:sldLayoutId xmlns:r="http://schemas.openxmlformats.org/officeDocument/2006/relationships" id="2147483649" r:id="Rf9c2e7345c2d4c7c"/>
   </p:sldLayoutIdLst>
   <p:txStyles>
     <p:titleStyle>
@@ -4046,7 +4060,7 @@
                   <a:srgbClr val="000000"/>
                 </a:solidFill>
               </a:rPr>
-              <a:t>模型只能用可驗證的工具與證據作答</a:t>
+              <a:t>Runtime：由問題到可驗證的 Market Brief</a:t>
             </a:r>
           </a:p>
         </p:txBody>
@@ -4148,7 +4162,7 @@
                   <a:srgbClr val="404040"/>
                 </a:solidFill>
               </a:rPr>
-              <a:t>真實 GLM + Pi + Python Facade + SQLite 已完成 live E2E；host finalizer 是市場事實回覆的最後 gate。</a:t>
+              <a:t>Input → Pi + Skills → typed tool loop → canonical data / citations → host finalizer → Market Brief / SSE</a:t>
             </a:r>
           </a:p>
         </p:txBody>
@@ -4234,7 +4248,7 @@
                   <a:srgbClr val="000000"/>
                 </a:solidFill>
               </a:rPr>
-              <a:t>Host finalizer</a:t>
+              <a:t>01  Input → Pi</a:t>
             </a:r>
           </a:p>
         </p:txBody>
@@ -4285,7 +4299,9 @@
                   <a:srgbClr val="404040"/>
                 </a:solidFill>
               </a:rPr>
-              <a:t>拒絕不支援的數字與 citation；完成後終止 tool loop</a:t>
+              <a:t>① 問題＋session scope
+② host 預載 Skills
+③ 45 秒 deadline／cancel</a:t>
             </a:r>
           </a:p>
         </p:txBody>
@@ -4371,7 +4387,7 @@
                   <a:srgbClr val="000000"/>
                 </a:solidFill>
               </a:rPr>
-              <a:t>Scoped handles</a:t>
+              <a:t>02  Tool loop</a:t>
             </a:r>
           </a:p>
         </p:txBody>
@@ -4422,7 +4438,9 @@
                   <a:srgbClr val="404040"/>
                 </a:solidFill>
               </a:rPr>
-              <a:t>模型只看短 alias；簽名 handle 保留在 host</a:t>
+              <a:t>④ Pi 選 5 個 typed tools
+⑤ Facade 套 scope／budget
+⑥ data + citations</a:t>
             </a:r>
           </a:p>
         </p:txBody>
@@ -4508,7 +4526,7 @@
                   <a:srgbClr val="000000"/>
                 </a:solidFill>
               </a:rPr>
-              <a:t>TC-01: 0 facts</a:t>
+              <a:t>03  Verify → brief</a:t>
             </a:r>
           </a:p>
         </p:txBody>
@@ -4559,11 +4577,65 @@
                   <a:srgbClr val="404040"/>
                 </a:solidFill>
               </a:rPr>
-              <a:t>Prime rent 無 coverage 時，回 unavailable、不杜撰</a:t>
+              <a:t>⑦ 核對 citation refs
+⑧ finalizer → brief v1
+⑨ SSE 只送 final artifact</a:t>
             </a:r>
           </a:p>
         </p:txBody>
       </p:sp>
+      <p:cxnSp>
+        <p:nvCxnSpPr>
+          <p:cNvPr id="28" name=""/>
+          <p:cNvCxnSpPr>
+            <a:stCxn xmlns:a="http://schemas.openxmlformats.org/drawingml/2006/main" id="4" idx="3"/>
+            <a:endCxn xmlns:a="http://schemas.openxmlformats.org/drawingml/2006/main" id="7" idx="1"/>
+          </p:cNvCxnSpPr>
+          <p:nvPr/>
+        </p:nvCxnSpPr>
+        <p:spPr>
+          <a:xfrm xmlns:a="http://schemas.openxmlformats.org/drawingml/2006/main">
+            <a:off x="3962400" y="4333875"/>
+            <a:ext cx="352425" cy="0"/>
+          </a:xfrm>
+          <a:prstGeom xmlns:a="http://schemas.openxmlformats.org/drawingml/2006/main" prst="straightConnector1">
+            <a:avLst/>
+          </a:prstGeom>
+          <a:ln xmlns:a="http://schemas.openxmlformats.org/drawingml/2006/main" w="28575">
+            <a:solidFill>
+              <a:srgbClr val="156082"/>
+            </a:solidFill>
+            <a:prstDash val="solid"/>
+            <a:tailEnd type="arrow" w="med" len="med"/>
+          </a:ln>
+        </p:spPr>
+      </p:cxnSp>
+      <p:cxnSp>
+        <p:nvCxnSpPr>
+          <p:cNvPr id="29" name=""/>
+          <p:cNvCxnSpPr>
+            <a:stCxn xmlns:a="http://schemas.openxmlformats.org/drawingml/2006/main" id="7" idx="3"/>
+            <a:endCxn xmlns:a="http://schemas.openxmlformats.org/drawingml/2006/main" id="10" idx="1"/>
+          </p:cNvCxnSpPr>
+          <p:nvPr/>
+        </p:nvCxnSpPr>
+        <p:spPr>
+          <a:xfrm xmlns:a="http://schemas.openxmlformats.org/drawingml/2006/main">
+            <a:off x="7877175" y="4333875"/>
+            <a:ext cx="352425" cy="0"/>
+          </a:xfrm>
+          <a:prstGeom xmlns:a="http://schemas.openxmlformats.org/drawingml/2006/main" prst="straightConnector1">
+            <a:avLst/>
+          </a:prstGeom>
+          <a:ln xmlns:a="http://schemas.openxmlformats.org/drawingml/2006/main" w="28575">
+            <a:solidFill>
+              <a:srgbClr val="156082"/>
+            </a:solidFill>
+            <a:prstDash val="solid"/>
+            <a:tailEnd type="arrow" w="med" len="med"/>
+          </a:ln>
+        </p:spPr>
+      </p:cxnSp>
     </p:spTree>
     <p:extLst>
       <p:ext uri="{BB962C8B-B14F-4D97-AF65-F5344CB8AC3E}">
@@ -4972,7 +5044,7 @@
           <p:nvPr/>
         </p:nvPicPr>
         <p:blipFill>
-          <a:blip xmlns:r="http://schemas.openxmlformats.org/officeDocument/2006/relationships" xmlns:a="http://schemas.openxmlformats.org/drawingml/2006/main" r:embed="Rb0e2356685694e9f"/>
+          <a:blip xmlns:r="http://schemas.openxmlformats.org/officeDocument/2006/relationships" xmlns:a="http://schemas.openxmlformats.org/drawingml/2006/main" r:embed="Rf7e8ddf0e8e94187"/>
           <a:srcRect xmlns:a="http://schemas.openxmlformats.org/drawingml/2006/main" l="0" t="31741" r="0" b="31741"/>
           <a:stretch xmlns:a="http://schemas.openxmlformats.org/drawingml/2006/main">
             <a:fillRect l="0" t="0" r="0" b="0"/>
@@ -5058,7 +5130,7 @@
                   <a:srgbClr val="000000"/>
                 </a:solidFill>
               </a:rPr>
-              <a:t>TC-01 無資料時回 unavailable；下一步補 sources</a:t>
+              <a:t>未來發展：從單一可信訊號走向多意圖研究</a:t>
             </a:r>
           </a:p>
         </p:txBody>
@@ -5148,34 +5220,189 @@
             <a:prstDash val="solid"/>
           </a:ln>
         </p:spPr>
-      </p:sp>
-      <p:pic>
-        <p:nvPicPr>
-          <p:cNvPr id="21" name=""/>
-          <p:cNvPicPr>
-            <a:picLocks xmlns:a="http://schemas.openxmlformats.org/drawingml/2006/main" noChangeAspect="1"/>
-          </p:cNvPicPr>
-          <p:nvPr/>
-        </p:nvPicPr>
-        <p:blipFill>
-          <a:blip xmlns:r="http://schemas.openxmlformats.org/officeDocument/2006/relationships" xmlns:a="http://schemas.openxmlformats.org/drawingml/2006/main" r:embed="Rce18a0fe39e54dfe"/>
-          <a:srcRect xmlns:a="http://schemas.openxmlformats.org/drawingml/2006/main" l="0" t="27708" r="0" b="27708"/>
-          <a:stretch xmlns:a="http://schemas.openxmlformats.org/drawingml/2006/main">
-            <a:fillRect l="0" t="0" r="0" b="0"/>
-          </a:stretch>
-        </p:blipFill>
-        <p:spPr>
-          <a:xfrm xmlns:a="http://schemas.openxmlformats.org/drawingml/2006/main">
-            <a:off x="400050" y="1695450"/>
-            <a:ext cx="5334000" cy="3238500"/>
-          </a:xfrm>
-          <a:prstGeom xmlns:a="http://schemas.openxmlformats.org/drawingml/2006/main" prst="roundRect">
-            <a:avLst>
-              <a:gd name="adj" fmla="val 4706"/>
-            </a:avLst>
-          </a:prstGeom>
-        </p:spPr>
-      </p:pic>
+        <p:txBody>
+          <a:bodyPr xmlns:a="http://schemas.openxmlformats.org/drawingml/2006/main"/>
+          <a:lstStyle xmlns:a="http://schemas.openxmlformats.org/drawingml/2006/main"/>
+          <a:p xmlns:a="http://schemas.openxmlformats.org/drawingml/2006/main">
+            <a:pPr>
+              <a:buNone/>
+              <a:defRPr sz="1500">
+                <a:solidFill>
+                  <a:srgbClr val="404040"/>
+                </a:solidFill>
+                <a:latin typeface="Calibri"/>
+                <a:ea typeface="Calibri"/>
+                <a:cs typeface="Calibri"/>
+              </a:defRPr>
+            </a:pPr>
+            <a:r>
+              <a:rPr sz="1500">
+                <a:solidFill>
+                  <a:srgbClr val="404040"/>
+                </a:solidFill>
+                <a:latin typeface="Calibri"/>
+                <a:ea typeface="Calibri"/>
+                <a:cs typeface="Calibri"/>
+              </a:rPr>
+              <a:t>擴充原則</a:t>
+            </a:r>
+          </a:p>
+          <a:p xmlns:a="http://schemas.openxmlformats.org/drawingml/2006/main">
+            <a:r>
+              <a:t/>
+            </a:r>
+          </a:p>
+          <a:p xmlns:a="http://schemas.openxmlformats.org/drawingml/2006/main">
+            <a:pPr>
+              <a:buNone/>
+              <a:defRPr sz="1500">
+                <a:solidFill>
+                  <a:srgbClr val="404040"/>
+                </a:solidFill>
+                <a:latin typeface="Calibri"/>
+                <a:ea typeface="Calibri"/>
+                <a:cs typeface="Calibri"/>
+              </a:defRPr>
+            </a:pPr>
+            <a:r>
+              <a:rPr sz="1500">
+                <a:solidFill>
+                  <a:srgbClr val="404040"/>
+                </a:solidFill>
+                <a:latin typeface="Calibri"/>
+                <a:ea typeface="Calibri"/>
+                <a:cs typeface="Calibri"/>
+              </a:rPr>
+              <a:t>不把搜尋結果直接當作市場事實。</a:t>
+            </a:r>
+          </a:p>
+          <a:p xmlns:a="http://schemas.openxmlformats.org/drawingml/2006/main">
+            <a:r>
+              <a:t/>
+            </a:r>
+          </a:p>
+          <a:p xmlns:a="http://schemas.openxmlformats.org/drawingml/2006/main">
+            <a:pPr>
+              <a:buNone/>
+              <a:defRPr sz="1500">
+                <a:solidFill>
+                  <a:srgbClr val="404040"/>
+                </a:solidFill>
+                <a:latin typeface="Calibri"/>
+                <a:ea typeface="Calibri"/>
+                <a:cs typeface="Calibri"/>
+              </a:defRPr>
+            </a:pPr>
+            <a:r>
+              <a:rPr sz="1500">
+                <a:solidFill>
+                  <a:srgbClr val="404040"/>
+                </a:solidFill>
+                <a:latin typeface="Calibri"/>
+                <a:ea typeface="Calibri"/>
+                <a:cs typeface="Calibri"/>
+              </a:rPr>
+              <a:t>每個新 intent 先定義：</a:t>
+            </a:r>
+          </a:p>
+          <a:p xmlns:a="http://schemas.openxmlformats.org/drawingml/2006/main">
+            <a:pPr>
+              <a:buNone/>
+              <a:defRPr sz="1500">
+                <a:solidFill>
+                  <a:srgbClr val="404040"/>
+                </a:solidFill>
+                <a:latin typeface="Calibri"/>
+                <a:ea typeface="Calibri"/>
+                <a:cs typeface="Calibri"/>
+              </a:defRPr>
+            </a:pPr>
+            <a:r>
+              <a:rPr sz="1500">
+                <a:solidFill>
+                  <a:srgbClr val="404040"/>
+                </a:solidFill>
+                <a:latin typeface="Calibri"/>
+                <a:ea typeface="Calibri"/>
+                <a:cs typeface="Calibri"/>
+              </a:rPr>
+              <a:t>• approved 資料範圍</a:t>
+            </a:r>
+          </a:p>
+          <a:p xmlns:a="http://schemas.openxmlformats.org/drawingml/2006/main">
+            <a:pPr>
+              <a:buNone/>
+              <a:defRPr sz="1500">
+                <a:solidFill>
+                  <a:srgbClr val="404040"/>
+                </a:solidFill>
+                <a:latin typeface="Calibri"/>
+                <a:ea typeface="Calibri"/>
+                <a:cs typeface="Calibri"/>
+              </a:defRPr>
+            </a:pPr>
+            <a:r>
+              <a:rPr sz="1500">
+                <a:solidFill>
+                  <a:srgbClr val="404040"/>
+                </a:solidFill>
+                <a:latin typeface="Calibri"/>
+                <a:ea typeface="Calibri"/>
+                <a:cs typeface="Calibri"/>
+              </a:rPr>
+              <a:t>• ad-hoc evidence / canonical data 分離</a:t>
+            </a:r>
+          </a:p>
+          <a:p xmlns:a="http://schemas.openxmlformats.org/drawingml/2006/main">
+            <a:pPr>
+              <a:buNone/>
+              <a:defRPr sz="1500">
+                <a:solidFill>
+                  <a:srgbClr val="404040"/>
+                </a:solidFill>
+                <a:latin typeface="Calibri"/>
+                <a:ea typeface="Calibri"/>
+                <a:cs typeface="Calibri"/>
+              </a:defRPr>
+            </a:pPr>
+            <a:r>
+              <a:rPr sz="1500">
+                <a:solidFill>
+                  <a:srgbClr val="404040"/>
+                </a:solidFill>
+                <a:latin typeface="Calibri"/>
+                <a:ea typeface="Calibri"/>
+                <a:cs typeface="Calibri"/>
+              </a:rPr>
+              <a:t>• evidence / freshness contract</a:t>
+            </a:r>
+          </a:p>
+          <a:p xmlns:a="http://schemas.openxmlformats.org/drawingml/2006/main">
+            <a:pPr>
+              <a:buNone/>
+              <a:defRPr sz="1500">
+                <a:solidFill>
+                  <a:srgbClr val="404040"/>
+                </a:solidFill>
+                <a:latin typeface="Calibri"/>
+                <a:ea typeface="Calibri"/>
+                <a:cs typeface="Calibri"/>
+              </a:defRPr>
+            </a:pPr>
+            <a:r>
+              <a:rPr sz="1500">
+                <a:solidFill>
+                  <a:srgbClr val="404040"/>
+                </a:solidFill>
+                <a:latin typeface="Calibri"/>
+                <a:ea typeface="Calibri"/>
+                <a:cs typeface="Calibri"/>
+              </a:rPr>
+              <a:t>• host 可授權的工具</a:t>
+            </a:r>
+          </a:p>
+        </p:txBody>
+      </p:sp>
       <p:sp>
         <p:nvSpPr>
           <p:cNvPr id="5" name="">
@@ -5222,7 +5449,7 @@
                   <a:srgbClr val="3D8DFF"/>
                 </a:solidFill>
               </a:rPr>
-              <a:t>Observed</a:t>
+              <a:t>Roadmap</a:t>
             </a:r>
           </a:p>
         </p:txBody>
@@ -5273,7 +5500,7 @@
                   <a:srgbClr val="000000"/>
                 </a:solidFill>
               </a:rPr>
-              <a:t>TC-01 中文原題</a:t>
+              <a:t>01  有來源的 news RAG</a:t>
             </a:r>
           </a:p>
           <a:p xmlns:a="http://schemas.openxmlformats.org/drawingml/2006/main">
@@ -5291,7 +5518,7 @@
                   <a:srgbClr val="000000"/>
                 </a:solidFill>
               </a:rPr>
-              <a:t>facts = 0 · sources hidden</a:t>
+              <a:t>approved / licensed corpus</a:t>
             </a:r>
           </a:p>
         </p:txBody>
@@ -5375,7 +5602,7 @@
                   <a:srgbClr val="3D8DFF"/>
                 </a:solidFill>
               </a:rPr>
-              <a:t>Next</a:t>
+              <a:t>02</a:t>
             </a:r>
           </a:p>
         </p:txBody>
@@ -5426,7 +5653,8 @@
                   <a:srgbClr val="404040"/>
                 </a:solidFill>
               </a:rPr>
-              <a:t>Prime rent：canonical source + evidence + freshness contract</a:t>
+              <a:t>Intent routing：data query / refresh /
+news research / unavailable</a:t>
             </a:r>
           </a:p>
         </p:txBody>
@@ -5510,7 +5738,7 @@
                   <a:srgbClr val="3D8DFF"/>
                 </a:solidFill>
               </a:rPr>
-              <a:t>Next</a:t>
+              <a:t>03</a:t>
             </a:r>
           </a:p>
         </p:txBody>
@@ -5561,7 +5789,7 @@
                   <a:srgbClr val="404040"/>
                 </a:solidFill>
               </a:rPr>
-              <a:t>Vacancy / transactions：approved workflow，再 promotion 到 product surface</a:t>
+              <a:t>Office source coverage + freshness monitoring</a:t>
             </a:r>
           </a:p>
         </p:txBody>
@@ -5645,7 +5873,7 @@
                   <a:srgbClr val="3D8DFF"/>
                 </a:solidFill>
               </a:rPr>
-              <a:t>Next</a:t>
+              <a:t>04</a:t>
             </a:r>
           </a:p>
         </p:txBody>
@@ -5696,7 +5924,8 @@
                   <a:srgbClr val="404040"/>
                 </a:solidFill>
               </a:rPr>
-              <a:t>Product operations：auth + monitoring，不擴大 tool authority</a:t>
+              <a:t>Production auth / tenancy（後續）
+安全擴展 host capability</a:t>
             </a:r>
           </a:p>
         </p:txBody>

</xml_diff>

<commit_message>
docs(demo): refresh real GLM UI evidence
</commit_message>
<xml_diff>
--- a/docs/London-Market-Desk-Architecture-and-Demo-2026-08-02.pptx
+++ b/docs/London-Market-Desk-Architecture-and-Demo-2026-08-02.pptx
@@ -2,18 +2,18 @@
 <file path=ppt/presentation.xml><?xml version="1.0" encoding="utf-8"?>
 <p:presentation xmlns:p="http://schemas.openxmlformats.org/presentationml/2006/main">
   <p:sldMasterIdLst>
-    <p:sldMasterId xmlns:r="http://schemas.openxmlformats.org/officeDocument/2006/relationships" id="2147483648" r:id="Re2dde098ffc94afc"/>
+    <p:sldMasterId xmlns:r="http://schemas.openxmlformats.org/officeDocument/2006/relationships" id="2147483648" r:id="Rcca299d43abb4e6f"/>
   </p:sldMasterIdLst>
   <p:notesMasterIdLst>
-    <p:notesMasterId xmlns:r="http://schemas.openxmlformats.org/officeDocument/2006/relationships" r:id="R78182f0f0b514020"/>
+    <p:notesMasterId xmlns:r="http://schemas.openxmlformats.org/officeDocument/2006/relationships" r:id="R2471373e5e8c4736"/>
   </p:notesMasterIdLst>
   <p:sldIdLst>
-    <p:sldId xmlns:r="http://schemas.openxmlformats.org/officeDocument/2006/relationships" id="256" r:id="R93adae1eb803462e"/>
-    <p:sldId xmlns:r="http://schemas.openxmlformats.org/officeDocument/2006/relationships" id="257" r:id="Rba3c77ec2b374b38"/>
-    <p:sldId xmlns:r="http://schemas.openxmlformats.org/officeDocument/2006/relationships" id="258" r:id="R5e72c8d7397943ef"/>
-    <p:sldId xmlns:r="http://schemas.openxmlformats.org/officeDocument/2006/relationships" id="259" r:id="R7e6957868f6d487d"/>
-    <p:sldId xmlns:r="http://schemas.openxmlformats.org/officeDocument/2006/relationships" id="260" r:id="R72b6dfa117d9468e"/>
-    <p:sldId xmlns:r="http://schemas.openxmlformats.org/officeDocument/2006/relationships" id="261" r:id="R4b08025d34a14976"/>
+    <p:sldId xmlns:r="http://schemas.openxmlformats.org/officeDocument/2006/relationships" id="256" r:id="Rddec8d7f33d24276"/>
+    <p:sldId xmlns:r="http://schemas.openxmlformats.org/officeDocument/2006/relationships" id="257" r:id="R088760b1b8cd49c7"/>
+    <p:sldId xmlns:r="http://schemas.openxmlformats.org/officeDocument/2006/relationships" id="258" r:id="R099c71e8801740bd"/>
+    <p:sldId xmlns:r="http://schemas.openxmlformats.org/officeDocument/2006/relationships" id="259" r:id="Rd577b4c3adcc45a6"/>
+    <p:sldId xmlns:r="http://schemas.openxmlformats.org/officeDocument/2006/relationships" id="260" r:id="R07d2606b0df149d8"/>
+    <p:sldId xmlns:r="http://schemas.openxmlformats.org/officeDocument/2006/relationships" id="261" r:id="Rf340ab493bf54520"/>
   </p:sldIdLst>
   <p:sldSz cx="12192000" cy="6858000"/>
   <p:notesSz cx="6858000" cy="9144000"/>
@@ -732,7 +732,7 @@
           <a:lstStyle xmlns:a="http://schemas.openxmlformats.org/drawingml/2006/main"/>
           <a:p xmlns:a="http://schemas.openxmlformats.org/drawingml/2006/main">
             <a:r>
-              <a:t>流程圖解說：1) 使用者問題建立 session scope；2) host 驗證並預載 Skills，將 Pi turn 限制為 45 秒；3) Pi 只可選用五個 typed data tools；4) Python Facade 套用 scoped handle、budget 和 read-only canonical boundary；5) query/citation 結果寫入 host-owned ledger；6) runtime-only finalizer 核對 claim/citation，產生 market_brief.v1；7) SSE 僅輸出已驗證的 final artifact。</a:t>
+              <a:t>本頁四張截圖均來自本 repo 的 Docker Demo，並在瀏覽器實際執行 Pi createAgentSession 與 glm/GLM-5.2。UI 不顯示未驗證的 streaming model prose；聊天區顯示 host-validated 數值與來源，右側只呈現 host-finalized market_brief.v1。Bank Rate 顯示 canonical fixture 5.25 percent、confidence、lineage 與 browser-safe Source 1；West End vacancy 正確顯示 unavailable，沒有生成 vacancy KPI。</a:t>
             </a:r>
           </a:p>
           <a:p xmlns:a="http://schemas.openxmlformats.org/drawingml/2006/main">
@@ -747,22 +747,22 @@
           </a:p>
           <a:p xmlns:a="http://schemas.openxmlformats.org/drawingml/2006/main">
             <a:r>
-              <a:t>- agent-runtime/README.md (controlled tool surface and market_brief.v1 contract)</a:t>
-            </a:r>
-          </a:p>
-          <a:p xmlns:a="http://schemas.openxmlformats.org/drawingml/2006/main">
-            <a:r>
-              <a:t>- agent-runtime/src/runtime.ts (45-second turn deadline)</a:t>
-            </a:r>
-          </a:p>
-          <a:p xmlns:a="http://schemas.openxmlformats.org/drawingml/2006/main">
-            <a:r>
-              <a:t>- agent-runtime/src/turn-runner.ts (prompt deadline and Pi session abort)</a:t>
-            </a:r>
-          </a:p>
-          <a:p xmlns:a="http://schemas.openxmlformats.org/drawingml/2006/main">
-            <a:r>
-              <a:t>- wiki/architecture/agent-runtime.md (skills, Facade, finalizer, citation ledger and SSE boundary)</a:t>
+              <a:t>- agent-runtime/src/boot.ts; agent-runtime/src/turn-runner.ts; agent-runtime/src/server.ts</a:t>
+            </a:r>
+          </a:p>
+          <a:p xmlns:a="http://schemas.openxmlformats.org/drawingml/2006/main">
+            <a:r>
+              <a:t>- agent-runtime/public/app.js; agent-runtime/public/index.html</a:t>
+            </a:r>
+          </a:p>
+          <a:p xmlns:a="http://schemas.openxmlformats.org/drawingml/2006/main">
+            <a:r>
+              <a:t>- tests/Test case.md (sanitized Docker browser / Pi / GLM acceptance traces)</a:t>
+            </a:r>
+          </a:p>
+          <a:p xmlns:a="http://schemas.openxmlformats.org/drawingml/2006/main">
+            <a:r>
+              <a:t>- Local acceptance captures generated from docker compose up --build --wait; no credentials are embedded in the screenshots</a:t>
             </a:r>
           </a:p>
         </p:txBody>
@@ -1015,7 +1015,7 @@
   </p:cSld>
   <p:clrMap bg1="lt1" tx1="dk1" bg2="lt2" tx2="dk2" accent1="accent1" accent2="accent2" accent3="accent3" accent4="accent4" accent5="accent5" accent6="accent6" hlink="hlink" folHlink="folHlink"/>
   <p:sldLayoutIdLst>
-    <p:sldLayoutId xmlns:r="http://schemas.openxmlformats.org/officeDocument/2006/relationships" id="2147483649" r:id="Rf9c2e7345c2d4c7c"/>
+    <p:sldLayoutId xmlns:r="http://schemas.openxmlformats.org/officeDocument/2006/relationships" id="2147483649" r:id="Rd7d40ac81ba8462a"/>
   </p:sldLayoutIdLst>
   <p:txStyles>
     <p:titleStyle>
@@ -4060,7 +4060,7 @@
                   <a:srgbClr val="000000"/>
                 </a:solidFill>
               </a:rPr>
-              <a:t>Runtime：由問題到可驗證的 Market Brief</a:t>
+              <a:t>真實 UI 驗收：Pi AgentSession × GLM-5.2</a:t>
             </a:r>
           </a:p>
         </p:txBody>
@@ -4162,17 +4162,42 @@
                   <a:srgbClr val="404040"/>
                 </a:solidFill>
               </a:rPr>
-              <a:t>Input → Pi + Skills → typed tool loop → canonical data / citations → host finalizer → Market Brief / SSE</a:t>
+              <a:t>Docker fixture disclosure → real GLM turn → host-validated result / lineage → safe unavailable</a:t>
             </a:r>
           </a:p>
         </p:txBody>
       </p:sp>
-      <p:sp>
-        <p:nvSpPr>
-          <p:cNvPr id="4" name="">
+      <p:pic>
+        <p:nvPicPr>
+          <p:cNvPr id="25" name=""/>
+          <p:cNvPicPr>
+            <a:picLocks xmlns:a="http://schemas.openxmlformats.org/drawingml/2006/main" noChangeAspect="1"/>
+          </p:cNvPicPr>
+          <p:nvPr/>
+        </p:nvPicPr>
+        <p:blipFill>
+          <a:blip xmlns:r="http://schemas.openxmlformats.org/officeDocument/2006/relationships" xmlns:a="http://schemas.openxmlformats.org/drawingml/2006/main" r:embed="Re1a4086aae2048cc"/>
+          <a:srcRect xmlns:a="http://schemas.openxmlformats.org/drawingml/2006/main" l="758" t="0" r="758" b="0"/>
+          <a:stretch xmlns:a="http://schemas.openxmlformats.org/drawingml/2006/main">
+            <a:fillRect l="0" t="0" r="0" b="0"/>
+          </a:stretch>
+        </p:blipFill>
+        <p:spPr>
+          <a:xfrm xmlns:a="http://schemas.openxmlformats.org/drawingml/2006/main">
+            <a:off x="400050" y="1924050"/>
+            <a:ext cx="5476875" cy="1847850"/>
+          </a:xfrm>
+          <a:prstGeom xmlns:a="http://schemas.openxmlformats.org/drawingml/2006/main" prst="rect">
+            <a:avLst/>
+          </a:prstGeom>
+        </p:spPr>
+      </p:pic>
+      <p:sp>
+        <p:nvSpPr>
+          <p:cNvPr id="15" name="ui-evidence-caption-1">
             <a:extLst xmlns:a="http://schemas.openxmlformats.org/drawingml/2006/main">
               <a:ext uri="{FF2B5EF4-FFF2-40B4-BE49-F238E27FC236}">
-                <a16:creationId xmlns:a16="http://schemas.microsoft.com/office/drawing/2014/main" id="{38B1E754-35D0-4B6C-A1B9-720962A19FCE}"/>
+                <a16:creationId xmlns:a16="http://schemas.microsoft.com/office/drawing/2014/main" id="{07D9BBDA-3178-4642-A71B-1891A6AD17FE}"/>
               </a:ext>
             </a:extLst>
           </p:cNvPr>
@@ -4183,43 +4208,8 @@
         </p:nvSpPr>
         <p:spPr>
           <a:xfrm xmlns:a="http://schemas.openxmlformats.org/drawingml/2006/main">
-            <a:off x="400050" y="2905125"/>
-            <a:ext cx="3562350" cy="2857500"/>
-          </a:xfrm>
-          <a:prstGeom xmlns:a="http://schemas.openxmlformats.org/drawingml/2006/main" prst="roundRect">
-            <a:avLst>
-              <a:gd name="adj" fmla="val 5333"/>
-            </a:avLst>
-          </a:prstGeom>
-          <a:solidFill xmlns:a="http://schemas.openxmlformats.org/drawingml/2006/main">
-            <a:srgbClr val="F2F2F2"/>
-          </a:solidFill>
-          <a:ln xmlns:a="http://schemas.openxmlformats.org/drawingml/2006/main" w="9525">
-            <a:solidFill>
-              <a:srgbClr val="B8BCC4"/>
-            </a:solidFill>
-            <a:prstDash val="solid"/>
-          </a:ln>
-        </p:spPr>
-      </p:sp>
-      <p:sp>
-        <p:nvSpPr>
-          <p:cNvPr id="5" name="">
-            <a:extLst xmlns:a="http://schemas.openxmlformats.org/drawingml/2006/main">
-              <a:ext uri="{FF2B5EF4-FFF2-40B4-BE49-F238E27FC236}">
-                <a16:creationId xmlns:a16="http://schemas.microsoft.com/office/drawing/2014/main" id="{0E24E07C-B48F-46BD-ACF7-31C7E6F40148}"/>
-              </a:ext>
-            </a:extLst>
-          </p:cNvPr>
-          <p:cNvSpPr>
-            <a:spLocks xmlns:a="http://schemas.openxmlformats.org/drawingml/2006/main" noGrp="1"/>
-          </p:cNvSpPr>
-          <p:nvPr/>
-        </p:nvSpPr>
-        <p:spPr>
-          <a:xfrm xmlns:a="http://schemas.openxmlformats.org/drawingml/2006/main">
-            <a:off x="685800" y="3381375"/>
-            <a:ext cx="2990850" cy="619125"/>
+            <a:off x="400050" y="1695450"/>
+            <a:ext cx="5476875" cy="190500"/>
           </a:xfrm>
           <a:prstGeom xmlns:a="http://schemas.openxmlformats.org/drawingml/2006/main" prst="rect">
             <a:avLst/>
@@ -4231,34 +4221,58 @@
           </a:ln>
         </p:spPr>
         <p:txBody>
-          <a:bodyPr xmlns:a="http://schemas.openxmlformats.org/drawingml/2006/main" anchor="t"/>
+          <a:bodyPr xmlns:a="http://schemas.openxmlformats.org/drawingml/2006/main"/>
           <a:lstStyle xmlns:a="http://schemas.openxmlformats.org/drawingml/2006/main"/>
           <a:p xmlns:a="http://schemas.openxmlformats.org/drawingml/2006/main">
-            <a:pPr algn="l">
-              <a:buNone/>
-              <a:defRPr sz="2400" b="1">
-                <a:solidFill>
-                  <a:srgbClr val="000000"/>
+            <a:pPr>
+              <a:defRPr sz="1125" b="1">
+                <a:solidFill>
+                  <a:srgbClr val="404040"/>
                 </a:solidFill>
               </a:defRPr>
             </a:pPr>
             <a:r>
-              <a:rPr sz="2400" b="1">
-                <a:solidFill>
-                  <a:srgbClr val="000000"/>
+              <a:rPr sz="1125" b="1">
+                <a:solidFill>
+                  <a:srgbClr val="404040"/>
                 </a:solidFill>
               </a:rPr>
-              <a:t>01  Input → Pi</a:t>
+              <a:t>01  Runtime + fixture disclosure</a:t>
             </a:r>
           </a:p>
         </p:txBody>
       </p:sp>
-      <p:sp>
-        <p:nvSpPr>
-          <p:cNvPr id="6" name="">
+      <p:pic>
+        <p:nvPicPr>
+          <p:cNvPr id="27" name=""/>
+          <p:cNvPicPr>
+            <a:picLocks xmlns:a="http://schemas.openxmlformats.org/drawingml/2006/main" noChangeAspect="1"/>
+          </p:cNvPicPr>
+          <p:nvPr/>
+        </p:nvPicPr>
+        <p:blipFill>
+          <a:blip xmlns:r="http://schemas.openxmlformats.org/officeDocument/2006/relationships" xmlns:a="http://schemas.openxmlformats.org/drawingml/2006/main" r:embed="R63f8567f4ee346aa"/>
+          <a:srcRect xmlns:a="http://schemas.openxmlformats.org/drawingml/2006/main" l="758" t="0" r="758" b="0"/>
+          <a:stretch xmlns:a="http://schemas.openxmlformats.org/drawingml/2006/main">
+            <a:fillRect l="0" t="0" r="0" b="0"/>
+          </a:stretch>
+        </p:blipFill>
+        <p:spPr>
+          <a:xfrm xmlns:a="http://schemas.openxmlformats.org/drawingml/2006/main">
+            <a:off x="6315075" y="1924050"/>
+            <a:ext cx="5476875" cy="1847850"/>
+          </a:xfrm>
+          <a:prstGeom xmlns:a="http://schemas.openxmlformats.org/drawingml/2006/main" prst="rect">
+            <a:avLst/>
+          </a:prstGeom>
+        </p:spPr>
+      </p:pic>
+      <p:sp>
+        <p:nvSpPr>
+          <p:cNvPr id="17" name="ui-evidence-caption-2">
             <a:extLst xmlns:a="http://schemas.openxmlformats.org/drawingml/2006/main">
               <a:ext uri="{FF2B5EF4-FFF2-40B4-BE49-F238E27FC236}">
-                <a16:creationId xmlns:a16="http://schemas.microsoft.com/office/drawing/2014/main" id="{110DB578-DE25-4404-8001-DC665C39CD54}"/>
+                <a16:creationId xmlns:a16="http://schemas.microsoft.com/office/drawing/2014/main" id="{E53C4E19-8003-4BC7-8583-B79501F68827}"/>
               </a:ext>
             </a:extLst>
           </p:cNvPr>
@@ -4269,8 +4283,8 @@
         </p:nvSpPr>
         <p:spPr>
           <a:xfrm xmlns:a="http://schemas.openxmlformats.org/drawingml/2006/main">
-            <a:off x="685800" y="4476750"/>
-            <a:ext cx="2990850" cy="838200"/>
+            <a:off x="6315075" y="1695450"/>
+            <a:ext cx="5476875" cy="190500"/>
           </a:xfrm>
           <a:prstGeom xmlns:a="http://schemas.openxmlformats.org/drawingml/2006/main" prst="rect">
             <a:avLst/>
@@ -4282,36 +4296,55 @@
           </a:ln>
         </p:spPr>
         <p:txBody>
-          <a:bodyPr xmlns:a="http://schemas.openxmlformats.org/drawingml/2006/main" anchor="t"/>
+          <a:bodyPr xmlns:a="http://schemas.openxmlformats.org/drawingml/2006/main"/>
           <a:lstStyle xmlns:a="http://schemas.openxmlformats.org/drawingml/2006/main"/>
           <a:p xmlns:a="http://schemas.openxmlformats.org/drawingml/2006/main">
-            <a:pPr algn="l">
-              <a:buNone/>
-              <a:defRPr sz="1725" b="0">
+            <a:pPr>
+              <a:defRPr sz="1125" b="1">
                 <a:solidFill>
                   <a:srgbClr val="404040"/>
                 </a:solidFill>
               </a:defRPr>
             </a:pPr>
             <a:r>
-              <a:rPr sz="1725" b="0">
+              <a:rPr sz="1125" b="1">
                 <a:solidFill>
                   <a:srgbClr val="404040"/>
                 </a:solidFill>
               </a:rPr>
-              <a:t>① 問題＋session scope
-② host 預載 Skills
-③ 45 秒 deadline／cancel</a:t>
+              <a:t>02  Real GLM answer + canonical facts</a:t>
             </a:r>
           </a:p>
         </p:txBody>
       </p:sp>
-      <p:sp>
-        <p:nvSpPr>
-          <p:cNvPr id="7" name="">
+      <p:pic>
+        <p:nvPicPr>
+          <p:cNvPr id="29" name=""/>
+          <p:cNvPicPr>
+            <a:picLocks xmlns:a="http://schemas.openxmlformats.org/drawingml/2006/main" noChangeAspect="1"/>
+          </p:cNvPicPr>
+          <p:nvPr/>
+        </p:nvPicPr>
+        <p:blipFill>
+          <a:blip xmlns:r="http://schemas.openxmlformats.org/officeDocument/2006/relationships" xmlns:a="http://schemas.openxmlformats.org/drawingml/2006/main" r:embed="R03cdcbe993f94393"/>
+          <a:stretch xmlns:a="http://schemas.openxmlformats.org/drawingml/2006/main"/>
+        </p:blipFill>
+        <p:spPr>
+          <a:xfrm xmlns:a="http://schemas.openxmlformats.org/drawingml/2006/main">
+            <a:off x="1856914" y="4229100"/>
+            <a:ext cx="2563147" cy="1847850"/>
+          </a:xfrm>
+          <a:prstGeom xmlns:a="http://schemas.openxmlformats.org/drawingml/2006/main" prst="rect">
+            <a:avLst/>
+          </a:prstGeom>
+        </p:spPr>
+      </p:pic>
+      <p:sp>
+        <p:nvSpPr>
+          <p:cNvPr id="19" name="ui-evidence-caption-3">
             <a:extLst xmlns:a="http://schemas.openxmlformats.org/drawingml/2006/main">
               <a:ext uri="{FF2B5EF4-FFF2-40B4-BE49-F238E27FC236}">
-                <a16:creationId xmlns:a16="http://schemas.microsoft.com/office/drawing/2014/main" id="{1FF9A6D7-8A58-4F94-8735-AA69D0F75D73}"/>
+                <a16:creationId xmlns:a16="http://schemas.microsoft.com/office/drawing/2014/main" id="{0B660FF5-9181-4441-AD59-804C4A84AB63}"/>
               </a:ext>
             </a:extLst>
           </p:cNvPr>
@@ -4322,43 +4355,8 @@
         </p:nvSpPr>
         <p:spPr>
           <a:xfrm xmlns:a="http://schemas.openxmlformats.org/drawingml/2006/main">
-            <a:off x="4314825" y="2905125"/>
-            <a:ext cx="3562350" cy="2857500"/>
-          </a:xfrm>
-          <a:prstGeom xmlns:a="http://schemas.openxmlformats.org/drawingml/2006/main" prst="roundRect">
-            <a:avLst>
-              <a:gd name="adj" fmla="val 5333"/>
-            </a:avLst>
-          </a:prstGeom>
-          <a:solidFill xmlns:a="http://schemas.openxmlformats.org/drawingml/2006/main">
-            <a:srgbClr val="F2F2F2"/>
-          </a:solidFill>
-          <a:ln xmlns:a="http://schemas.openxmlformats.org/drawingml/2006/main" w="9525">
-            <a:solidFill>
-              <a:srgbClr val="B8BCC4"/>
-            </a:solidFill>
-            <a:prstDash val="solid"/>
-          </a:ln>
-        </p:spPr>
-      </p:sp>
-      <p:sp>
-        <p:nvSpPr>
-          <p:cNvPr id="8" name="">
-            <a:extLst xmlns:a="http://schemas.openxmlformats.org/drawingml/2006/main">
-              <a:ext uri="{FF2B5EF4-FFF2-40B4-BE49-F238E27FC236}">
-                <a16:creationId xmlns:a16="http://schemas.microsoft.com/office/drawing/2014/main" id="{4FA62A2A-8141-4E3B-95CB-F8CA12BBA125}"/>
-              </a:ext>
-            </a:extLst>
-          </p:cNvPr>
-          <p:cNvSpPr>
-            <a:spLocks xmlns:a="http://schemas.openxmlformats.org/drawingml/2006/main" noGrp="1"/>
-          </p:cNvSpPr>
-          <p:nvPr/>
-        </p:nvSpPr>
-        <p:spPr>
-          <a:xfrm xmlns:a="http://schemas.openxmlformats.org/drawingml/2006/main">
-            <a:off x="4600575" y="3381375"/>
-            <a:ext cx="2990850" cy="619125"/>
+            <a:off x="400050" y="4000500"/>
+            <a:ext cx="5476875" cy="190500"/>
           </a:xfrm>
           <a:prstGeom xmlns:a="http://schemas.openxmlformats.org/drawingml/2006/main" prst="rect">
             <a:avLst/>
@@ -4370,34 +4368,58 @@
           </a:ln>
         </p:spPr>
         <p:txBody>
-          <a:bodyPr xmlns:a="http://schemas.openxmlformats.org/drawingml/2006/main" anchor="t"/>
+          <a:bodyPr xmlns:a="http://schemas.openxmlformats.org/drawingml/2006/main"/>
           <a:lstStyle xmlns:a="http://schemas.openxmlformats.org/drawingml/2006/main"/>
           <a:p xmlns:a="http://schemas.openxmlformats.org/drawingml/2006/main">
-            <a:pPr algn="l">
-              <a:buNone/>
-              <a:defRPr sz="2400" b="1">
-                <a:solidFill>
-                  <a:srgbClr val="000000"/>
+            <a:pPr>
+              <a:defRPr sz="1125" b="1">
+                <a:solidFill>
+                  <a:srgbClr val="404040"/>
                 </a:solidFill>
               </a:defRPr>
             </a:pPr>
             <a:r>
-              <a:rPr sz="2400" b="1">
-                <a:solidFill>
-                  <a:srgbClr val="000000"/>
+              <a:rPr sz="1125" b="1">
+                <a:solidFill>
+                  <a:srgbClr val="404040"/>
                 </a:solidFill>
               </a:rPr>
-              <a:t>02  Tool loop</a:t>
+              <a:t>03  Host lineage + safe Source 1</a:t>
             </a:r>
           </a:p>
         </p:txBody>
       </p:sp>
-      <p:sp>
-        <p:nvSpPr>
-          <p:cNvPr id="9" name="">
+      <p:pic>
+        <p:nvPicPr>
+          <p:cNvPr id="31" name=""/>
+          <p:cNvPicPr>
+            <a:picLocks xmlns:a="http://schemas.openxmlformats.org/drawingml/2006/main" noChangeAspect="1"/>
+          </p:cNvPicPr>
+          <p:nvPr/>
+        </p:nvPicPr>
+        <p:blipFill>
+          <a:blip xmlns:r="http://schemas.openxmlformats.org/officeDocument/2006/relationships" xmlns:a="http://schemas.openxmlformats.org/drawingml/2006/main" r:embed="R8ba9df74d8584b04"/>
+          <a:srcRect xmlns:a="http://schemas.openxmlformats.org/drawingml/2006/main" l="758" t="0" r="758" b="0"/>
+          <a:stretch xmlns:a="http://schemas.openxmlformats.org/drawingml/2006/main">
+            <a:fillRect l="0" t="0" r="0" b="0"/>
+          </a:stretch>
+        </p:blipFill>
+        <p:spPr>
+          <a:xfrm xmlns:a="http://schemas.openxmlformats.org/drawingml/2006/main">
+            <a:off x="6315075" y="4229100"/>
+            <a:ext cx="5476875" cy="1847850"/>
+          </a:xfrm>
+          <a:prstGeom xmlns:a="http://schemas.openxmlformats.org/drawingml/2006/main" prst="rect">
+            <a:avLst/>
+          </a:prstGeom>
+        </p:spPr>
+      </p:pic>
+      <p:sp>
+        <p:nvSpPr>
+          <p:cNvPr id="21" name="ui-evidence-caption-4">
             <a:extLst xmlns:a="http://schemas.openxmlformats.org/drawingml/2006/main">
               <a:ext uri="{FF2B5EF4-FFF2-40B4-BE49-F238E27FC236}">
-                <a16:creationId xmlns:a16="http://schemas.microsoft.com/office/drawing/2014/main" id="{B7CF9062-C7CD-4C7A-B1E7-496D7D36CA9D}"/>
+                <a16:creationId xmlns:a16="http://schemas.microsoft.com/office/drawing/2014/main" id="{E062B3A5-AC35-4366-9F1B-7E933920D50A}"/>
               </a:ext>
             </a:extLst>
           </p:cNvPr>
@@ -4408,8 +4430,8 @@
         </p:nvSpPr>
         <p:spPr>
           <a:xfrm xmlns:a="http://schemas.openxmlformats.org/drawingml/2006/main">
-            <a:off x="4600575" y="4476750"/>
-            <a:ext cx="2990850" cy="838200"/>
+            <a:off x="6315075" y="4000500"/>
+            <a:ext cx="5476875" cy="190500"/>
           </a:xfrm>
           <a:prstGeom xmlns:a="http://schemas.openxmlformats.org/drawingml/2006/main" prst="rect">
             <a:avLst/>
@@ -4421,221 +4443,27 @@
           </a:ln>
         </p:spPr>
         <p:txBody>
-          <a:bodyPr xmlns:a="http://schemas.openxmlformats.org/drawingml/2006/main" anchor="t"/>
+          <a:bodyPr xmlns:a="http://schemas.openxmlformats.org/drawingml/2006/main"/>
           <a:lstStyle xmlns:a="http://schemas.openxmlformats.org/drawingml/2006/main"/>
           <a:p xmlns:a="http://schemas.openxmlformats.org/drawingml/2006/main">
-            <a:pPr algn="l">
-              <a:buNone/>
-              <a:defRPr sz="1725" b="0">
+            <a:pPr>
+              <a:defRPr sz="1125" b="1">
                 <a:solidFill>
                   <a:srgbClr val="404040"/>
                 </a:solidFill>
               </a:defRPr>
             </a:pPr>
             <a:r>
-              <a:rPr sz="1725" b="0">
+              <a:rPr sz="1125" b="1">
                 <a:solidFill>
                   <a:srgbClr val="404040"/>
                 </a:solidFill>
               </a:rPr>
-              <a:t>④ Pi 選 5 個 typed tools
-⑤ Facade 套 scope／budget
-⑥ data + citations</a:t>
+              <a:t>04  Safe unavailable — no invented vacancy KPI</a:t>
             </a:r>
           </a:p>
         </p:txBody>
       </p:sp>
-      <p:sp>
-        <p:nvSpPr>
-          <p:cNvPr id="10" name="">
-            <a:extLst xmlns:a="http://schemas.openxmlformats.org/drawingml/2006/main">
-              <a:ext uri="{FF2B5EF4-FFF2-40B4-BE49-F238E27FC236}">
-                <a16:creationId xmlns:a16="http://schemas.microsoft.com/office/drawing/2014/main" id="{E03961F0-BDD2-445F-BAF0-0A917F004E60}"/>
-              </a:ext>
-            </a:extLst>
-          </p:cNvPr>
-          <p:cNvSpPr>
-            <a:spLocks xmlns:a="http://schemas.openxmlformats.org/drawingml/2006/main" noGrp="1"/>
-          </p:cNvSpPr>
-          <p:nvPr/>
-        </p:nvSpPr>
-        <p:spPr>
-          <a:xfrm xmlns:a="http://schemas.openxmlformats.org/drawingml/2006/main">
-            <a:off x="8229600" y="2905125"/>
-            <a:ext cx="3562350" cy="2857500"/>
-          </a:xfrm>
-          <a:prstGeom xmlns:a="http://schemas.openxmlformats.org/drawingml/2006/main" prst="roundRect">
-            <a:avLst>
-              <a:gd name="adj" fmla="val 5333"/>
-            </a:avLst>
-          </a:prstGeom>
-          <a:solidFill xmlns:a="http://schemas.openxmlformats.org/drawingml/2006/main">
-            <a:srgbClr val="F2F2F2"/>
-          </a:solidFill>
-          <a:ln xmlns:a="http://schemas.openxmlformats.org/drawingml/2006/main" w="9525">
-            <a:solidFill>
-              <a:srgbClr val="B8BCC4"/>
-            </a:solidFill>
-            <a:prstDash val="solid"/>
-          </a:ln>
-        </p:spPr>
-      </p:sp>
-      <p:sp>
-        <p:nvSpPr>
-          <p:cNvPr id="11" name="">
-            <a:extLst xmlns:a="http://schemas.openxmlformats.org/drawingml/2006/main">
-              <a:ext uri="{FF2B5EF4-FFF2-40B4-BE49-F238E27FC236}">
-                <a16:creationId xmlns:a16="http://schemas.microsoft.com/office/drawing/2014/main" id="{EC117B1B-60F0-487F-AA46-D2A982F62E27}"/>
-              </a:ext>
-            </a:extLst>
-          </p:cNvPr>
-          <p:cNvSpPr>
-            <a:spLocks xmlns:a="http://schemas.openxmlformats.org/drawingml/2006/main" noGrp="1"/>
-          </p:cNvSpPr>
-          <p:nvPr/>
-        </p:nvSpPr>
-        <p:spPr>
-          <a:xfrm xmlns:a="http://schemas.openxmlformats.org/drawingml/2006/main">
-            <a:off x="8515350" y="3381375"/>
-            <a:ext cx="2990850" cy="619125"/>
-          </a:xfrm>
-          <a:prstGeom xmlns:a="http://schemas.openxmlformats.org/drawingml/2006/main" prst="rect">
-            <a:avLst/>
-          </a:prstGeom>
-          <a:noFill xmlns:a="http://schemas.openxmlformats.org/drawingml/2006/main"/>
-          <a:ln xmlns:a="http://schemas.openxmlformats.org/drawingml/2006/main" w="0">
-            <a:noFill/>
-            <a:prstDash val="solid"/>
-          </a:ln>
-        </p:spPr>
-        <p:txBody>
-          <a:bodyPr xmlns:a="http://schemas.openxmlformats.org/drawingml/2006/main" anchor="t"/>
-          <a:lstStyle xmlns:a="http://schemas.openxmlformats.org/drawingml/2006/main"/>
-          <a:p xmlns:a="http://schemas.openxmlformats.org/drawingml/2006/main">
-            <a:pPr algn="l">
-              <a:buNone/>
-              <a:defRPr sz="2400" b="1">
-                <a:solidFill>
-                  <a:srgbClr val="000000"/>
-                </a:solidFill>
-              </a:defRPr>
-            </a:pPr>
-            <a:r>
-              <a:rPr sz="2400" b="1">
-                <a:solidFill>
-                  <a:srgbClr val="000000"/>
-                </a:solidFill>
-              </a:rPr>
-              <a:t>03  Verify → brief</a:t>
-            </a:r>
-          </a:p>
-        </p:txBody>
-      </p:sp>
-      <p:sp>
-        <p:nvSpPr>
-          <p:cNvPr id="12" name="">
-            <a:extLst xmlns:a="http://schemas.openxmlformats.org/drawingml/2006/main">
-              <a:ext uri="{FF2B5EF4-FFF2-40B4-BE49-F238E27FC236}">
-                <a16:creationId xmlns:a16="http://schemas.microsoft.com/office/drawing/2014/main" id="{B2F804D0-86BC-48D1-A03E-DB6E07D8E906}"/>
-              </a:ext>
-            </a:extLst>
-          </p:cNvPr>
-          <p:cNvSpPr>
-            <a:spLocks xmlns:a="http://schemas.openxmlformats.org/drawingml/2006/main" noGrp="1"/>
-          </p:cNvSpPr>
-          <p:nvPr/>
-        </p:nvSpPr>
-        <p:spPr>
-          <a:xfrm xmlns:a="http://schemas.openxmlformats.org/drawingml/2006/main">
-            <a:off x="8515350" y="4476750"/>
-            <a:ext cx="2990850" cy="838200"/>
-          </a:xfrm>
-          <a:prstGeom xmlns:a="http://schemas.openxmlformats.org/drawingml/2006/main" prst="rect">
-            <a:avLst/>
-          </a:prstGeom>
-          <a:noFill xmlns:a="http://schemas.openxmlformats.org/drawingml/2006/main"/>
-          <a:ln xmlns:a="http://schemas.openxmlformats.org/drawingml/2006/main" w="0">
-            <a:noFill/>
-            <a:prstDash val="solid"/>
-          </a:ln>
-        </p:spPr>
-        <p:txBody>
-          <a:bodyPr xmlns:a="http://schemas.openxmlformats.org/drawingml/2006/main" anchor="t"/>
-          <a:lstStyle xmlns:a="http://schemas.openxmlformats.org/drawingml/2006/main"/>
-          <a:p xmlns:a="http://schemas.openxmlformats.org/drawingml/2006/main">
-            <a:pPr algn="l">
-              <a:buNone/>
-              <a:defRPr sz="1725" b="0">
-                <a:solidFill>
-                  <a:srgbClr val="404040"/>
-                </a:solidFill>
-              </a:defRPr>
-            </a:pPr>
-            <a:r>
-              <a:rPr sz="1725" b="0">
-                <a:solidFill>
-                  <a:srgbClr val="404040"/>
-                </a:solidFill>
-              </a:rPr>
-              <a:t>⑦ 核對 citation refs
-⑧ finalizer → brief v1
-⑨ SSE 只送 final artifact</a:t>
-            </a:r>
-          </a:p>
-        </p:txBody>
-      </p:sp>
-      <p:cxnSp>
-        <p:nvCxnSpPr>
-          <p:cNvPr id="28" name=""/>
-          <p:cNvCxnSpPr>
-            <a:stCxn xmlns:a="http://schemas.openxmlformats.org/drawingml/2006/main" id="4" idx="3"/>
-            <a:endCxn xmlns:a="http://schemas.openxmlformats.org/drawingml/2006/main" id="7" idx="1"/>
-          </p:cNvCxnSpPr>
-          <p:nvPr/>
-        </p:nvCxnSpPr>
-        <p:spPr>
-          <a:xfrm xmlns:a="http://schemas.openxmlformats.org/drawingml/2006/main">
-            <a:off x="3962400" y="4333875"/>
-            <a:ext cx="352425" cy="0"/>
-          </a:xfrm>
-          <a:prstGeom xmlns:a="http://schemas.openxmlformats.org/drawingml/2006/main" prst="straightConnector1">
-            <a:avLst/>
-          </a:prstGeom>
-          <a:ln xmlns:a="http://schemas.openxmlformats.org/drawingml/2006/main" w="28575">
-            <a:solidFill>
-              <a:srgbClr val="156082"/>
-            </a:solidFill>
-            <a:prstDash val="solid"/>
-            <a:tailEnd type="arrow" w="med" len="med"/>
-          </a:ln>
-        </p:spPr>
-      </p:cxnSp>
-      <p:cxnSp>
-        <p:nvCxnSpPr>
-          <p:cNvPr id="29" name=""/>
-          <p:cNvCxnSpPr>
-            <a:stCxn xmlns:a="http://schemas.openxmlformats.org/drawingml/2006/main" id="7" idx="3"/>
-            <a:endCxn xmlns:a="http://schemas.openxmlformats.org/drawingml/2006/main" id="10" idx="1"/>
-          </p:cNvCxnSpPr>
-          <p:nvPr/>
-        </p:nvCxnSpPr>
-        <p:spPr>
-          <a:xfrm xmlns:a="http://schemas.openxmlformats.org/drawingml/2006/main">
-            <a:off x="7877175" y="4333875"/>
-            <a:ext cx="352425" cy="0"/>
-          </a:xfrm>
-          <a:prstGeom xmlns:a="http://schemas.openxmlformats.org/drawingml/2006/main" prst="straightConnector1">
-            <a:avLst/>
-          </a:prstGeom>
-          <a:ln xmlns:a="http://schemas.openxmlformats.org/drawingml/2006/main" w="28575">
-            <a:solidFill>
-              <a:srgbClr val="156082"/>
-            </a:solidFill>
-            <a:prstDash val="solid"/>
-            <a:tailEnd type="arrow" w="med" len="med"/>
-          </a:ln>
-        </p:spPr>
-      </p:cxnSp>
     </p:spTree>
     <p:extLst>
       <p:ext uri="{BB962C8B-B14F-4D97-AF65-F5344CB8AC3E}">
@@ -5044,7 +4872,7 @@
           <p:nvPr/>
         </p:nvPicPr>
         <p:blipFill>
-          <a:blip xmlns:r="http://schemas.openxmlformats.org/officeDocument/2006/relationships" xmlns:a="http://schemas.openxmlformats.org/drawingml/2006/main" r:embed="Rf7e8ddf0e8e94187"/>
+          <a:blip xmlns:r="http://schemas.openxmlformats.org/officeDocument/2006/relationships" xmlns:a="http://schemas.openxmlformats.org/drawingml/2006/main" r:embed="Rd16c197282374d72"/>
           <a:srcRect xmlns:a="http://schemas.openxmlformats.org/drawingml/2006/main" l="0" t="31741" r="0" b="31741"/>
           <a:stretch xmlns:a="http://schemas.openxmlformats.org/drawingml/2006/main">
             <a:fillRect l="0" t="0" r="0" b="0"/>

</xml_diff>